<commit_message>
PPT Individual: Taapaca (2026-01-01 → 2026-02-18)
</commit_message>
<xml_diff>
--- a/docs/sentinel2/Taapaca/reportes/Taapaca_Evaluacion_Mensual_2026-02.pptx
+++ b/docs/sentinel2/Taapaca/reportes/Taapaca_Evaluacion_Mensual_2026-02.pptx
@@ -3814,7 +3814,7 @@
             <a:pPr algn="ctr"/>
             <a:r>
               <a:rPr sz="1200"/>
-              <a:t>Imagenes Sentinel 2 L2A color verdadero, Time Lapse 05 enero  04 febrero 2026</a:t>
+              <a:t>Imagenes Sentinel 2 L2A color verdadero, Time Lapse 05 enero  14 febrero 2026</a:t>
             </a:r>
           </a:p>
         </p:txBody>
@@ -3850,7 +3850,7 @@
             <a:pPr algn="ctr"/>
             <a:r>
               <a:rPr sz="1200"/>
-              <a:t>Imagenes Sentinel 2 L2A Falso color, Time Lapse 05 enero  04 febrero 2026</a:t>
+              <a:t>Imagenes Sentinel 2 L2A Falso color, Time Lapse 05 enero  14 febrero 2026</a:t>
             </a:r>
           </a:p>
         </p:txBody>
@@ -3900,16 +3900,8 @@
           <a:p>
             <a:pPr algn="ctr"/>
             <a:r>
-              <a:rPr lang="es-MX" sz="1400" b="1" dirty="0"/>
-              <a:t>No se registran datos asociados a actividad superficial en volcán </a:t>
-            </a:r>
-            <a:r>
-              <a:rPr lang="es-MX" sz="1400" b="1" dirty="0" err="1"/>
-              <a:t>Tupungatito</a:t>
-            </a:r>
-            <a:r>
-              <a:rPr lang="es-MX" sz="1400" b="1" dirty="0"/>
-              <a:t> durante el mes de diciembre 2025</a:t>
+              <a:rPr sz="1400" b="1"/>
+              <a:t>No se registran datos asociados a actividad superficial en volcán Taapaca durante el mes de febrero 2026</a:t>
             </a:r>
             <a:endParaRPr lang="es-CL" sz="1400" b="1" dirty="0"/>
           </a:p>

</xml_diff>

<commit_message>
Actualizacion automatica: 2026-03-01 10:32
</commit_message>
<xml_diff>
--- a/docs/sentinel2/Taapaca/reportes/Taapaca_Evaluacion_Mensual_2026-02.pptx
+++ b/docs/sentinel2/Taapaca/reportes/Taapaca_Evaluacion_Mensual_2026-02.pptx
@@ -3814,7 +3814,7 @@
             <a:pPr algn="ctr"/>
             <a:r>
               <a:rPr sz="1200"/>
-              <a:t>Imagenes Sentinel 2 L2A color verdadero, Time Lapse 05 enero  14 febrero 2026</a:t>
+              <a:t>Imagenes Sentinel 2 L2A color verdadero, Time Lapse 05 enero → 14 febrero 2026</a:t>
             </a:r>
           </a:p>
         </p:txBody>
@@ -3850,7 +3850,7 @@
             <a:pPr algn="ctr"/>
             <a:r>
               <a:rPr sz="1200"/>
-              <a:t>Imagenes Sentinel 2 L2A Falso color, Time Lapse 05 enero  14 febrero 2026</a:t>
+              <a:t>Imagenes Sentinel 2 L2A Falso color, Time Lapse 05 enero → 14 febrero 2026</a:t>
             </a:r>
           </a:p>
         </p:txBody>

</xml_diff>